<commit_message>
Simplify presentation charts and clarify fingerprint presets
</commit_message>
<xml_diff>
--- a/demo/Presentation_Demo.pptx
+++ b/demo/Presentation_Demo.pptx
@@ -5,7 +5,7 @@
     <p:sldMasterId id="2147483648" r:id="rId1"/>
   </p:sldMasterIdLst>
   <p:notesMasterIdLst>
-    <p:notesMasterId r:id="rId13"/>
+    <p:notesMasterId r:id="rId14"/>
   </p:notesMasterIdLst>
   <p:sldIdLst>
     <p:sldId id="256" r:id="rId2"/>
@@ -19,6 +19,7 @@
     <p:sldId id="264" r:id="rId10"/>
     <p:sldId id="265" r:id="rId11"/>
     <p:sldId id="266" r:id="rId12"/>
+    <p:sldId id="267" r:id="rId13"/>
   </p:sldIdLst>
   <p:sldSz cx="12192000" cy="6858000"/>
   <p:notesSz cx="6858000" cy="9144000"/>
@@ -171,7 +172,7 @@
                   <a:lstStyle/>
                   <a:p>
                     <a:r>
-                      <a:rPr sz="1425">
+                      <a:rPr sz="1200">
                         <a:solidFill>
                           <a:srgbClr val="161E2E"/>
                         </a:solidFill>
@@ -179,7 +180,7 @@
                         <a:ea typeface="Calibri"/>
                         <a:cs typeface="Calibri"/>
                       </a:rPr>
-                      <a:t> </a:t>
+                      <a:t>0.107</a:t>
                     </a:r>
                   </a:p>
                 </c:rich>
@@ -197,7 +198,7 @@
                   <c15:showDataLabelsRange val="0"/>
                 </c:ext>
                 <c:ext xmlns:c16="http://schemas.microsoft.com/office/drawing/2014/chart" uri="{C3380CC4-5D6E-409C-BE32-E72D297353CC}">
-                  <c16:uniqueId val="{00000000-BA2F-4311-A049-F22D40C36CC7}"/>
+                  <c16:uniqueId val="{00000000-9FFF-4767-8CE5-A9445DFF47A3}"/>
                 </c:ext>
               </c:extLst>
             </c:dLbl>
@@ -209,7 +210,7 @@
                   <a:lstStyle/>
                   <a:p>
                     <a:r>
-                      <a:rPr sz="1425">
+                      <a:rPr sz="1200">
                         <a:solidFill>
                           <a:srgbClr val="161E2E"/>
                         </a:solidFill>
@@ -217,7 +218,7 @@
                         <a:ea typeface="Calibri"/>
                         <a:cs typeface="Calibri"/>
                       </a:rPr>
-                      <a:t>†</a:t>
+                      <a:t>0.127</a:t>
                     </a:r>
                   </a:p>
                 </c:rich>
@@ -235,7 +236,7 @@
                   <c15:showDataLabelsRange val="0"/>
                 </c:ext>
                 <c:ext xmlns:c16="http://schemas.microsoft.com/office/drawing/2014/chart" uri="{C3380CC4-5D6E-409C-BE32-E72D297353CC}">
-                  <c16:uniqueId val="{00000001-BA2F-4311-A049-F22D40C36CC7}"/>
+                  <c16:uniqueId val="{00000001-9FFF-4767-8CE5-A9445DFF47A3}"/>
                 </c:ext>
               </c:extLst>
             </c:dLbl>
@@ -247,7 +248,7 @@
                   <a:lstStyle/>
                   <a:p>
                     <a:r>
-                      <a:rPr sz="1425">
+                      <a:rPr sz="1200">
                         <a:solidFill>
                           <a:srgbClr val="161E2E"/>
                         </a:solidFill>
@@ -255,7 +256,7 @@
                         <a:ea typeface="Calibri"/>
                         <a:cs typeface="Calibri"/>
                       </a:rPr>
-                      <a:t>ns</a:t>
+                      <a:t>0.102</a:t>
                     </a:r>
                   </a:p>
                 </c:rich>
@@ -273,7 +274,7 @@
                   <c15:showDataLabelsRange val="0"/>
                 </c:ext>
                 <c:ext xmlns:c16="http://schemas.microsoft.com/office/drawing/2014/chart" uri="{C3380CC4-5D6E-409C-BE32-E72D297353CC}">
-                  <c16:uniqueId val="{00000002-BA2F-4311-A049-F22D40C36CC7}"/>
+                  <c16:uniqueId val="{00000002-9FFF-4767-8CE5-A9445DFF47A3}"/>
                 </c:ext>
               </c:extLst>
             </c:dLbl>
@@ -285,7 +286,7 @@
                   <a:lstStyle/>
                   <a:p>
                     <a:r>
-                      <a:rPr sz="1425">
+                      <a:rPr sz="1200">
                         <a:solidFill>
                           <a:srgbClr val="161E2E"/>
                         </a:solidFill>
@@ -293,7 +294,7 @@
                         <a:ea typeface="Calibri"/>
                         <a:cs typeface="Calibri"/>
                       </a:rPr>
-                      <a:t>ns</a:t>
+                      <a:t>0.100</a:t>
                     </a:r>
                   </a:p>
                 </c:rich>
@@ -311,7 +312,7 @@
                   <c15:showDataLabelsRange val="0"/>
                 </c:ext>
                 <c:ext xmlns:c16="http://schemas.microsoft.com/office/drawing/2014/chart" uri="{C3380CC4-5D6E-409C-BE32-E72D297353CC}">
-                  <c16:uniqueId val="{00000003-BA2F-4311-A049-F22D40C36CC7}"/>
+                  <c16:uniqueId val="{00000003-9FFF-4767-8CE5-A9445DFF47A3}"/>
                 </c:ext>
               </c:extLst>
             </c:dLbl>
@@ -387,7 +388,7 @@
               </c14:invertSolidFillFmt>
             </c:ext>
             <c:ext xmlns:c16="http://schemas.microsoft.com/office/drawing/2014/chart" uri="{C3380CC4-5D6E-409C-BE32-E72D297353CC}">
-              <c16:uniqueId val="{00000004-BA2F-4311-A049-F22D40C36CC7}"/>
+              <c16:uniqueId val="{00000004-9FFF-4767-8CE5-A9445DFF47A3}"/>
             </c:ext>
           </c:extLst>
         </c:ser>
@@ -412,7 +413,7 @@
                   <a:lstStyle/>
                   <a:p>
                     <a:r>
-                      <a:rPr sz="1425">
+                      <a:rPr sz="1200">
                         <a:solidFill>
                           <a:srgbClr val="161E2E"/>
                         </a:solidFill>
@@ -420,7 +421,7 @@
                         <a:ea typeface="Calibri"/>
                         <a:cs typeface="Calibri"/>
                       </a:rPr>
-                      <a:t> </a:t>
+                      <a:t>0.098</a:t>
                     </a:r>
                   </a:p>
                 </c:rich>
@@ -438,7 +439,7 @@
                   <c15:showDataLabelsRange val="0"/>
                 </c:ext>
                 <c:ext xmlns:c16="http://schemas.microsoft.com/office/drawing/2014/chart" uri="{C3380CC4-5D6E-409C-BE32-E72D297353CC}">
-                  <c16:uniqueId val="{00000005-BA2F-4311-A049-F22D40C36CC7}"/>
+                  <c16:uniqueId val="{00000005-9FFF-4767-8CE5-A9445DFF47A3}"/>
                 </c:ext>
               </c:extLst>
             </c:dLbl>
@@ -450,7 +451,7 @@
                   <a:lstStyle/>
                   <a:p>
                     <a:r>
-                      <a:rPr sz="1425">
+                      <a:rPr sz="1200">
                         <a:solidFill>
                           <a:srgbClr val="161E2E"/>
                         </a:solidFill>
@@ -458,7 +459,7 @@
                         <a:ea typeface="Calibri"/>
                         <a:cs typeface="Calibri"/>
                       </a:rPr>
-                      <a:t>ns</a:t>
+                      <a:t>0.095</a:t>
                     </a:r>
                   </a:p>
                 </c:rich>
@@ -476,7 +477,7 @@
                   <c15:showDataLabelsRange val="0"/>
                 </c:ext>
                 <c:ext xmlns:c16="http://schemas.microsoft.com/office/drawing/2014/chart" uri="{C3380CC4-5D6E-409C-BE32-E72D297353CC}">
-                  <c16:uniqueId val="{00000006-BA2F-4311-A049-F22D40C36CC7}"/>
+                  <c16:uniqueId val="{00000006-9FFF-4767-8CE5-A9445DFF47A3}"/>
                 </c:ext>
               </c:extLst>
             </c:dLbl>
@@ -488,7 +489,7 @@
                   <a:lstStyle/>
                   <a:p>
                     <a:r>
-                      <a:rPr sz="1425">
+                      <a:rPr sz="1200">
                         <a:solidFill>
                           <a:srgbClr val="161E2E"/>
                         </a:solidFill>
@@ -496,7 +497,7 @@
                         <a:ea typeface="Calibri"/>
                         <a:cs typeface="Calibri"/>
                       </a:rPr>
-                      <a:t>*</a:t>
+                      <a:t>0.055</a:t>
                     </a:r>
                   </a:p>
                 </c:rich>
@@ -514,7 +515,7 @@
                   <c15:showDataLabelsRange val="0"/>
                 </c:ext>
                 <c:ext xmlns:c16="http://schemas.microsoft.com/office/drawing/2014/chart" uri="{C3380CC4-5D6E-409C-BE32-E72D297353CC}">
-                  <c16:uniqueId val="{00000007-BA2F-4311-A049-F22D40C36CC7}"/>
+                  <c16:uniqueId val="{00000007-9FFF-4767-8CE5-A9445DFF47A3}"/>
                 </c:ext>
               </c:extLst>
             </c:dLbl>
@@ -526,7 +527,7 @@
                   <a:lstStyle/>
                   <a:p>
                     <a:r>
-                      <a:rPr sz="1425">
+                      <a:rPr sz="1200">
                         <a:solidFill>
                           <a:srgbClr val="161E2E"/>
                         </a:solidFill>
@@ -534,7 +535,7 @@
                         <a:ea typeface="Calibri"/>
                         <a:cs typeface="Calibri"/>
                       </a:rPr>
-                      <a:t>*</a:t>
+                      <a:t>0.055</a:t>
                     </a:r>
                   </a:p>
                 </c:rich>
@@ -552,7 +553,7 @@
                   <c15:showDataLabelsRange val="0"/>
                 </c:ext>
                 <c:ext xmlns:c16="http://schemas.microsoft.com/office/drawing/2014/chart" uri="{C3380CC4-5D6E-409C-BE32-E72D297353CC}">
-                  <c16:uniqueId val="{00000008-BA2F-4311-A049-F22D40C36CC7}"/>
+                  <c16:uniqueId val="{00000008-9FFF-4767-8CE5-A9445DFF47A3}"/>
                 </c:ext>
               </c:extLst>
             </c:dLbl>
@@ -628,7 +629,7 @@
               </c14:invertSolidFillFmt>
             </c:ext>
             <c:ext xmlns:c16="http://schemas.microsoft.com/office/drawing/2014/chart" uri="{C3380CC4-5D6E-409C-BE32-E72D297353CC}">
-              <c16:uniqueId val="{00000009-BA2F-4311-A049-F22D40C36CC7}"/>
+              <c16:uniqueId val="{00000009-9FFF-4767-8CE5-A9445DFF47A3}"/>
             </c:ext>
           </c:extLst>
         </c:ser>
@@ -814,7 +815,7 @@
                   <a:lstStyle/>
                   <a:p>
                     <a:r>
-                      <a:rPr sz="1425">
+                      <a:rPr sz="1200">
                         <a:solidFill>
                           <a:srgbClr val="161E2E"/>
                         </a:solidFill>
@@ -822,7 +823,7 @@
                         <a:ea typeface="Calibri"/>
                         <a:cs typeface="Calibri"/>
                       </a:rPr>
-                      <a:t> </a:t>
+                      <a:t>0.078</a:t>
                     </a:r>
                   </a:p>
                 </c:rich>
@@ -840,7 +841,7 @@
                   <c15:showDataLabelsRange val="0"/>
                 </c:ext>
                 <c:ext xmlns:c16="http://schemas.microsoft.com/office/drawing/2014/chart" uri="{C3380CC4-5D6E-409C-BE32-E72D297353CC}">
-                  <c16:uniqueId val="{00000000-13BD-4CCF-B445-D8E3CDD73556}"/>
+                  <c16:uniqueId val="{00000000-B0B2-4F79-8D86-7FCADA87970E}"/>
                 </c:ext>
               </c:extLst>
             </c:dLbl>
@@ -852,7 +853,7 @@
                   <a:lstStyle/>
                   <a:p>
                     <a:r>
-                      <a:rPr sz="1425">
+                      <a:rPr sz="1200">
                         <a:solidFill>
                           <a:srgbClr val="161E2E"/>
                         </a:solidFill>
@@ -860,7 +861,7 @@
                         <a:ea typeface="Calibri"/>
                         <a:cs typeface="Calibri"/>
                       </a:rPr>
-                      <a:t>ns</a:t>
+                      <a:t>0.082</a:t>
                     </a:r>
                   </a:p>
                 </c:rich>
@@ -878,7 +879,7 @@
                   <c15:showDataLabelsRange val="0"/>
                 </c:ext>
                 <c:ext xmlns:c16="http://schemas.microsoft.com/office/drawing/2014/chart" uri="{C3380CC4-5D6E-409C-BE32-E72D297353CC}">
-                  <c16:uniqueId val="{00000001-13BD-4CCF-B445-D8E3CDD73556}"/>
+                  <c16:uniqueId val="{00000001-B0B2-4F79-8D86-7FCADA87970E}"/>
                 </c:ext>
               </c:extLst>
             </c:dLbl>
@@ -890,7 +891,7 @@
                   <a:lstStyle/>
                   <a:p>
                     <a:r>
-                      <a:rPr sz="1425">
+                      <a:rPr sz="1200">
                         <a:solidFill>
                           <a:srgbClr val="161E2E"/>
                         </a:solidFill>
@@ -898,7 +899,7 @@
                         <a:ea typeface="Calibri"/>
                         <a:cs typeface="Calibri"/>
                       </a:rPr>
-                      <a:t>*</a:t>
+                      <a:t>0.058</a:t>
                     </a:r>
                   </a:p>
                 </c:rich>
@@ -916,7 +917,7 @@
                   <c15:showDataLabelsRange val="0"/>
                 </c:ext>
                 <c:ext xmlns:c16="http://schemas.microsoft.com/office/drawing/2014/chart" uri="{C3380CC4-5D6E-409C-BE32-E72D297353CC}">
-                  <c16:uniqueId val="{00000002-13BD-4CCF-B445-D8E3CDD73556}"/>
+                  <c16:uniqueId val="{00000002-B0B2-4F79-8D86-7FCADA87970E}"/>
                 </c:ext>
               </c:extLst>
             </c:dLbl>
@@ -928,7 +929,7 @@
                   <a:lstStyle/>
                   <a:p>
                     <a:r>
-                      <a:rPr sz="1425">
+                      <a:rPr sz="1200">
                         <a:solidFill>
                           <a:srgbClr val="161E2E"/>
                         </a:solidFill>
@@ -936,7 +937,7 @@
                         <a:ea typeface="Calibri"/>
                         <a:cs typeface="Calibri"/>
                       </a:rPr>
-                      <a:t>*</a:t>
+                      <a:t>0.057</a:t>
                     </a:r>
                   </a:p>
                 </c:rich>
@@ -954,7 +955,7 @@
                   <c15:showDataLabelsRange val="0"/>
                 </c:ext>
                 <c:ext xmlns:c16="http://schemas.microsoft.com/office/drawing/2014/chart" uri="{C3380CC4-5D6E-409C-BE32-E72D297353CC}">
-                  <c16:uniqueId val="{00000003-13BD-4CCF-B445-D8E3CDD73556}"/>
+                  <c16:uniqueId val="{00000003-B0B2-4F79-8D86-7FCADA87970E}"/>
                 </c:ext>
               </c:extLst>
             </c:dLbl>
@@ -1030,7 +1031,7 @@
               </c14:invertSolidFillFmt>
             </c:ext>
             <c:ext xmlns:c16="http://schemas.microsoft.com/office/drawing/2014/chart" uri="{C3380CC4-5D6E-409C-BE32-E72D297353CC}">
-              <c16:uniqueId val="{00000004-13BD-4CCF-B445-D8E3CDD73556}"/>
+              <c16:uniqueId val="{00000004-B0B2-4F79-8D86-7FCADA87970E}"/>
             </c:ext>
           </c:extLst>
         </c:ser>
@@ -1055,7 +1056,7 @@
                   <a:lstStyle/>
                   <a:p>
                     <a:r>
-                      <a:rPr sz="1425">
+                      <a:rPr sz="1200">
                         <a:solidFill>
                           <a:srgbClr val="161E2E"/>
                         </a:solidFill>
@@ -1063,7 +1064,7 @@
                         <a:ea typeface="Calibri"/>
                         <a:cs typeface="Calibri"/>
                       </a:rPr>
-                      <a:t> </a:t>
+                      <a:t>0.070</a:t>
                     </a:r>
                   </a:p>
                 </c:rich>
@@ -1081,7 +1082,7 @@
                   <c15:showDataLabelsRange val="0"/>
                 </c:ext>
                 <c:ext xmlns:c16="http://schemas.microsoft.com/office/drawing/2014/chart" uri="{C3380CC4-5D6E-409C-BE32-E72D297353CC}">
-                  <c16:uniqueId val="{00000005-13BD-4CCF-B445-D8E3CDD73556}"/>
+                  <c16:uniqueId val="{00000005-B0B2-4F79-8D86-7FCADA87970E}"/>
                 </c:ext>
               </c:extLst>
             </c:dLbl>
@@ -1093,7 +1094,7 @@
                   <a:lstStyle/>
                   <a:p>
                     <a:r>
-                      <a:rPr sz="1425">
+                      <a:rPr sz="1200">
                         <a:solidFill>
                           <a:srgbClr val="161E2E"/>
                         </a:solidFill>
@@ -1101,7 +1102,7 @@
                         <a:ea typeface="Calibri"/>
                         <a:cs typeface="Calibri"/>
                       </a:rPr>
-                      <a:t>ns</a:t>
+                      <a:t>0.065</a:t>
                     </a:r>
                   </a:p>
                 </c:rich>
@@ -1119,7 +1120,7 @@
                   <c15:showDataLabelsRange val="0"/>
                 </c:ext>
                 <c:ext xmlns:c16="http://schemas.microsoft.com/office/drawing/2014/chart" uri="{C3380CC4-5D6E-409C-BE32-E72D297353CC}">
-                  <c16:uniqueId val="{00000006-13BD-4CCF-B445-D8E3CDD73556}"/>
+                  <c16:uniqueId val="{00000006-B0B2-4F79-8D86-7FCADA87970E}"/>
                 </c:ext>
               </c:extLst>
             </c:dLbl>
@@ -1131,7 +1132,7 @@
                   <a:lstStyle/>
                   <a:p>
                     <a:r>
-                      <a:rPr sz="1425">
+                      <a:rPr sz="1200">
                         <a:solidFill>
                           <a:srgbClr val="161E2E"/>
                         </a:solidFill>
@@ -1139,7 +1140,7 @@
                         <a:ea typeface="Calibri"/>
                         <a:cs typeface="Calibri"/>
                       </a:rPr>
-                      <a:t>*</a:t>
+                      <a:t>0.024</a:t>
                     </a:r>
                   </a:p>
                 </c:rich>
@@ -1157,7 +1158,7 @@
                   <c15:showDataLabelsRange val="0"/>
                 </c:ext>
                 <c:ext xmlns:c16="http://schemas.microsoft.com/office/drawing/2014/chart" uri="{C3380CC4-5D6E-409C-BE32-E72D297353CC}">
-                  <c16:uniqueId val="{00000007-13BD-4CCF-B445-D8E3CDD73556}"/>
+                  <c16:uniqueId val="{00000007-B0B2-4F79-8D86-7FCADA87970E}"/>
                 </c:ext>
               </c:extLst>
             </c:dLbl>
@@ -1169,7 +1170,7 @@
                   <a:lstStyle/>
                   <a:p>
                     <a:r>
-                      <a:rPr sz="1425">
+                      <a:rPr sz="1200">
                         <a:solidFill>
                           <a:srgbClr val="161E2E"/>
                         </a:solidFill>
@@ -1177,7 +1178,7 @@
                         <a:ea typeface="Calibri"/>
                         <a:cs typeface="Calibri"/>
                       </a:rPr>
-                      <a:t>*</a:t>
+                      <a:t>0.024</a:t>
                     </a:r>
                   </a:p>
                 </c:rich>
@@ -1195,7 +1196,7 @@
                   <c15:showDataLabelsRange val="0"/>
                 </c:ext>
                 <c:ext xmlns:c16="http://schemas.microsoft.com/office/drawing/2014/chart" uri="{C3380CC4-5D6E-409C-BE32-E72D297353CC}">
-                  <c16:uniqueId val="{00000008-13BD-4CCF-B445-D8E3CDD73556}"/>
+                  <c16:uniqueId val="{00000008-B0B2-4F79-8D86-7FCADA87970E}"/>
                 </c:ext>
               </c:extLst>
             </c:dLbl>
@@ -1271,7 +1272,7 @@
               </c14:invertSolidFillFmt>
             </c:ext>
             <c:ext xmlns:c16="http://schemas.microsoft.com/office/drawing/2014/chart" uri="{C3380CC4-5D6E-409C-BE32-E72D297353CC}">
-              <c16:uniqueId val="{00000009-13BD-4CCF-B445-D8E3CDD73556}"/>
+              <c16:uniqueId val="{00000009-B0B2-4F79-8D86-7FCADA87970E}"/>
             </c:ext>
           </c:extLst>
         </c:ser>
@@ -1465,7 +1466,7 @@
                         <a:ea typeface="Calibri"/>
                         <a:cs typeface="Calibri"/>
                       </a:rPr>
-                      <a:t> </a:t>
+                      <a:t>0.219</a:t>
                     </a:r>
                   </a:p>
                 </c:rich>
@@ -1483,7 +1484,7 @@
                   <c15:showDataLabelsRange val="0"/>
                 </c:ext>
                 <c:ext xmlns:c16="http://schemas.microsoft.com/office/drawing/2014/chart" uri="{C3380CC4-5D6E-409C-BE32-E72D297353CC}">
-                  <c16:uniqueId val="{00000000-1684-459C-9312-E0C6049C09C4}"/>
+                  <c16:uniqueId val="{00000000-8D79-4786-AE09-188E9E91B668}"/>
                 </c:ext>
               </c:extLst>
             </c:dLbl>
@@ -1503,7 +1504,7 @@
                         <a:ea typeface="Calibri"/>
                         <a:cs typeface="Calibri"/>
                       </a:rPr>
-                      <a:t> </a:t>
+                      <a:t>0.215</a:t>
                     </a:r>
                   </a:p>
                 </c:rich>
@@ -1521,7 +1522,7 @@
                   <c15:showDataLabelsRange val="0"/>
                 </c:ext>
                 <c:ext xmlns:c16="http://schemas.microsoft.com/office/drawing/2014/chart" uri="{C3380CC4-5D6E-409C-BE32-E72D297353CC}">
-                  <c16:uniqueId val="{00000001-1684-459C-9312-E0C6049C09C4}"/>
+                  <c16:uniqueId val="{00000001-8D79-4786-AE09-188E9E91B668}"/>
                 </c:ext>
               </c:extLst>
             </c:dLbl>
@@ -1585,7 +1586,7 @@
               </c14:invertSolidFillFmt>
             </c:ext>
             <c:ext xmlns:c16="http://schemas.microsoft.com/office/drawing/2014/chart" uri="{C3380CC4-5D6E-409C-BE32-E72D297353CC}">
-              <c16:uniqueId val="{00000002-1684-459C-9312-E0C6049C09C4}"/>
+              <c16:uniqueId val="{00000002-8D79-4786-AE09-188E9E91B668}"/>
             </c:ext>
           </c:extLst>
         </c:ser>
@@ -1618,7 +1619,7 @@
                         <a:ea typeface="Calibri"/>
                         <a:cs typeface="Calibri"/>
                       </a:rPr>
-                      <a:t>*</a:t>
+                      <a:t>0.290</a:t>
                     </a:r>
                   </a:p>
                 </c:rich>
@@ -1636,7 +1637,7 @@
                   <c15:showDataLabelsRange val="0"/>
                 </c:ext>
                 <c:ext xmlns:c16="http://schemas.microsoft.com/office/drawing/2014/chart" uri="{C3380CC4-5D6E-409C-BE32-E72D297353CC}">
-                  <c16:uniqueId val="{00000003-1684-459C-9312-E0C6049C09C4}"/>
+                  <c16:uniqueId val="{00000003-8D79-4786-AE09-188E9E91B668}"/>
                 </c:ext>
               </c:extLst>
             </c:dLbl>
@@ -1656,7 +1657,7 @@
                         <a:ea typeface="Calibri"/>
                         <a:cs typeface="Calibri"/>
                       </a:rPr>
-                      <a:t>*</a:t>
+                      <a:t>0.284</a:t>
                     </a:r>
                   </a:p>
                 </c:rich>
@@ -1674,7 +1675,7 @@
                   <c15:showDataLabelsRange val="0"/>
                 </c:ext>
                 <c:ext xmlns:c16="http://schemas.microsoft.com/office/drawing/2014/chart" uri="{C3380CC4-5D6E-409C-BE32-E72D297353CC}">
-                  <c16:uniqueId val="{00000004-1684-459C-9312-E0C6049C09C4}"/>
+                  <c16:uniqueId val="{00000004-8D79-4786-AE09-188E9E91B668}"/>
                 </c:ext>
               </c:extLst>
             </c:dLbl>
@@ -1738,7 +1739,7 @@
               </c14:invertSolidFillFmt>
             </c:ext>
             <c:ext xmlns:c16="http://schemas.microsoft.com/office/drawing/2014/chart" uri="{C3380CC4-5D6E-409C-BE32-E72D297353CC}">
-              <c16:uniqueId val="{00000005-1684-459C-9312-E0C6049C09C4}"/>
+              <c16:uniqueId val="{00000005-8D79-4786-AE09-188E9E91B668}"/>
             </c:ext>
           </c:extLst>
         </c:ser>
@@ -1771,7 +1772,7 @@
                         <a:ea typeface="Calibri"/>
                         <a:cs typeface="Calibri"/>
                       </a:rPr>
-                      <a:t>*</a:t>
+                      <a:t>0.317</a:t>
                     </a:r>
                   </a:p>
                 </c:rich>
@@ -1789,7 +1790,7 @@
                   <c15:showDataLabelsRange val="0"/>
                 </c:ext>
                 <c:ext xmlns:c16="http://schemas.microsoft.com/office/drawing/2014/chart" uri="{C3380CC4-5D6E-409C-BE32-E72D297353CC}">
-                  <c16:uniqueId val="{00000006-1684-459C-9312-E0C6049C09C4}"/>
+                  <c16:uniqueId val="{00000006-8D79-4786-AE09-188E9E91B668}"/>
                 </c:ext>
               </c:extLst>
             </c:dLbl>
@@ -1809,7 +1810,7 @@
                         <a:ea typeface="Calibri"/>
                         <a:cs typeface="Calibri"/>
                       </a:rPr>
-                      <a:t>*</a:t>
+                      <a:t>0.314</a:t>
                     </a:r>
                   </a:p>
                 </c:rich>
@@ -1827,7 +1828,7 @@
                   <c15:showDataLabelsRange val="0"/>
                 </c:ext>
                 <c:ext xmlns:c16="http://schemas.microsoft.com/office/drawing/2014/chart" uri="{C3380CC4-5D6E-409C-BE32-E72D297353CC}">
-                  <c16:uniqueId val="{00000007-1684-459C-9312-E0C6049C09C4}"/>
+                  <c16:uniqueId val="{00000007-8D79-4786-AE09-188E9E91B668}"/>
                 </c:ext>
               </c:extLst>
             </c:dLbl>
@@ -1891,7 +1892,7 @@
               </c14:invertSolidFillFmt>
             </c:ext>
             <c:ext xmlns:c16="http://schemas.microsoft.com/office/drawing/2014/chart" uri="{C3380CC4-5D6E-409C-BE32-E72D297353CC}">
-              <c16:uniqueId val="{00000008-1684-459C-9312-E0C6049C09C4}"/>
+              <c16:uniqueId val="{00000008-8D79-4786-AE09-188E9E91B668}"/>
             </c:ext>
           </c:extLst>
         </c:ser>
@@ -2122,7 +2123,7 @@
             </a:lvl1pPr>
           </a:lstStyle>
           <a:p>
-            <a:fld id="{C9DC5B5A-12B0-4C01-8FD8-A1394BFFB4F0}" type="datetimeFigureOut">
+            <a:fld id="{4D8AE813-36B7-49AB-92F0-22AFFF378C6B}" type="datetimeFigureOut">
               <a:rPr lang="LID4096" smtClean="0"/>
               <a:t>09/16/2026</a:t>
             </a:fld>
@@ -2281,7 +2282,7 @@
             </a:lvl1pPr>
           </a:lstStyle>
           <a:p>
-            <a:fld id="{0B0BD399-28D9-477A-B44F-E0B13036A6F2}" type="slidenum">
+            <a:fld id="{9AFB35E2-C658-457F-9E35-7F5362887325}" type="slidenum">
               <a:rPr lang="LID4096" smtClean="0"/>
               <a:t>‹#›</a:t>
             </a:fld>
@@ -2292,7 +2293,7 @@
     </p:spTree>
     <p:extLst>
       <p:ext uri="{BB962C8B-B14F-4D97-AF65-F5344CB8AC3E}">
-        <p14:creationId xmlns:p14="http://schemas.microsoft.com/office/powerpoint/2010/main" val="4010517290"/>
+        <p14:creationId xmlns:p14="http://schemas.microsoft.com/office/powerpoint/2010/main" val="2021991195"/>
       </p:ext>
     </p:extLst>
   </p:cSld>
@@ -2534,7 +2535,89 @@
     </p:spTree>
     <p:extLst>
       <p:ext uri="{BB962C8B-B14F-4D97-AF65-F5344CB8AC3E}">
-        <p14:creationId xmlns:p14="http://schemas.microsoft.com/office/powerpoint/2010/main" val="2406400938"/>
+        <p14:creationId xmlns:p14="http://schemas.microsoft.com/office/powerpoint/2010/main" val="3632216650"/>
+      </p:ext>
+    </p:extLst>
+  </p:cSld>
+  <p:clrMapOvr>
+    <a:masterClrMapping/>
+  </p:clrMapOvr>
+</p:notes>
+</file>
+
+<file path=ppt/notesSlides/notesSlide11.xml><?xml version="1.0" encoding="utf-8"?>
+<p:notes xmlns:a="http://schemas.openxmlformats.org/drawingml/2006/main" xmlns:r="http://schemas.openxmlformats.org/officeDocument/2006/relationships" xmlns:p="http://schemas.openxmlformats.org/presentationml/2006/main">
+  <p:cSld>
+    <p:spTree>
+      <p:nvGrpSpPr>
+        <p:cNvPr id="1" name=""/>
+        <p:cNvGrpSpPr/>
+        <p:nvPr/>
+      </p:nvGrpSpPr>
+      <p:grpSpPr>
+        <a:xfrm>
+          <a:off x="0" y="0"/>
+          <a:ext cx="0" cy="0"/>
+          <a:chOff x="0" y="0"/>
+          <a:chExt cx="0" cy="0"/>
+        </a:xfrm>
+      </p:grpSpPr>
+      <p:sp>
+        <p:nvSpPr>
+          <p:cNvPr id="2" name="Slide Image Placeholder 1"/>
+          <p:cNvSpPr>
+            <a:spLocks noGrp="1" noRot="1" noChangeAspect="1"/>
+          </p:cNvSpPr>
+          <p:nvPr>
+            <p:ph type="sldImg"/>
+          </p:nvPr>
+        </p:nvSpPr>
+        <p:spPr/>
+      </p:sp>
+      <p:sp>
+        <p:nvSpPr>
+          <p:cNvPr id="3" name="Notes Placeholder 2"/>
+          <p:cNvSpPr>
+            <a:spLocks noGrp="1"/>
+          </p:cNvSpPr>
+          <p:nvPr>
+            <p:ph type="body" idx="1"/>
+          </p:nvPr>
+        </p:nvSpPr>
+        <p:spPr/>
+        <p:txBody>
+          <a:bodyPr/>
+          <a:lstStyle/>
+          <a:p>
+            <a:r>
+              <a:t>Thank the audience and invite questions. Seman Libbiss and Paz Flashner.</a:t>
+            </a:r>
+          </a:p>
+        </p:txBody>
+      </p:sp>
+      <p:sp>
+        <p:nvSpPr>
+          <p:cNvPr id="4" name="Slide Number Placeholder 3"/>
+          <p:cNvSpPr>
+            <a:spLocks noGrp="1"/>
+          </p:cNvSpPr>
+          <p:nvPr>
+            <p:ph type="sldNum" idx="5"/>
+          </p:nvPr>
+        </p:nvSpPr>
+        <p:spPr/>
+        <p:txBody>
+          <a:bodyPr/>
+          <a:lstStyle/>
+          <a:p>
+            <a:endParaRPr/>
+          </a:p>
+        </p:txBody>
+      </p:sp>
+    </p:spTree>
+    <p:extLst>
+      <p:ext uri="{BB962C8B-B14F-4D97-AF65-F5344CB8AC3E}">
+        <p14:creationId xmlns:p14="http://schemas.microsoft.com/office/powerpoint/2010/main" val="2285123645"/>
       </p:ext>
     </p:extLst>
   </p:cSld>
@@ -3009,12 +3092,12 @@
           <a:lstStyle/>
           <a:p>
             <a:r>
-              <a:t>This is our new central analysis. We flatten each whole phase-normalized path and divide by square root of 200. Euclidean distance then means RMS coordinate difference. Energy and MMD compare the generated set with the held-out set and also account for within-set variation. At eight dimensions both variational models improve on spline, and this survives both multiple-testing corrections and equalizing the training variation of the two axes. Their difference from each other is not significant. At three dimensions, raw MMD favors them over spline, but raw energy does not, and balanced-axis MMD no longer passes BH. This is why the eight-dimensional conclusion is stronger. These are phase-path results, not a validation of physical timing. Source: production/trajectory_distribution_2026_09_13/summary.csv, paired_comparisons.csv and protocol.json. Bars show participant-balanced means after seed averaging. Markers compare each bar with the reference named above the chart, using the saved adjusted paired tests. In model-comparison charts, * means BH and Holm both pass .05; dagger means BH only; ns means neither. The personal-center chart uses its original BH-corrected control family. There are no error bars, and no p-value has been converted into an uncertainty interval.</a:t>
-            </a:r>
-          </a:p>
-          <a:p>
-            <a:r>
-              <a:t>Explain: each generated path and each recorded query path is a 200-coordinate vector. This is a set-to-set comparison, not pairing trial 1 with trial 1. Each participant contributes one score per model after averaging training seeds. The bars give equal weight to each of the 28 participants. A significance marker indicates a difference, not automatically an improvement; lower bars are better. Three-dimensional CAE energy is significantly worse under BH only. Exact values and adjusted p-values are in the source course_slides.json and the trajectory_distribution_2026_09_13 CSVs. The selected plot uses raw RMS coordinates, so energy has units cm and MMD² is dimensionless. A smaller distance does not by itself prove absolute physiological realism.</a:t>
+              <a:t>This is our new central analysis. We flatten each whole phase-normalized path and divide by square root of 200. Euclidean distance then means RMS coordinate difference. Energy and MMD compare the generated set with the held-out set and also account for within-set variation. At eight dimensions both variational models improve on spline, and this survives both multiple-testing corrections and equalizing the training variation of the two axes. Their difference from each other is not significant. At three dimensions, raw MMD favors them over spline, but raw energy does not, and balanced-axis MMD no longer passes BH. This is why the eight-dimensional conclusion is stronger. These are phase-path results, not a validation of physical timing. Source: production/trajectory_distribution_2026_09_13/summary.csv, paired_comparisons.csv and protocol.json.</a:t>
+            </a:r>
+          </a:p>
+          <a:p>
+            <a:r>
+              <a:t>Each generated path and each recorded query path is a 200-coordinate vector. This is a set-to-set comparison, not pairing trial 1 with trial 1. Each participant contributes one score per model after averaging training seeds. Bars give equal weight to each of the 28 participants; labels are means rounded to three decimals. Three-dimensional CAE energy is significantly worse under BH only. Exact values and adjusted p-values are in source course_slides.json and the trajectory_distribution_2026_09_13 CSVs. The selected plot uses raw RMS coordinates, so energy has units cm and MMD² is dimensionless. The full-path adjustment family contains 80 comparisons. At n=8, the VAE/CVAE improvement over spline also survives balancing the axes. A smaller distance does not by itself prove absolute physiological realism.</a:t>
             </a:r>
           </a:p>
         </p:txBody>
@@ -3041,7 +3124,7 @@
     </p:spTree>
     <p:extLst>
       <p:ext uri="{BB962C8B-B14F-4D97-AF65-F5344CB8AC3E}">
-        <p14:creationId xmlns:p14="http://schemas.microsoft.com/office/powerpoint/2010/main" val="1563021405"/>
+        <p14:creationId xmlns:p14="http://schemas.microsoft.com/office/powerpoint/2010/main" val="3094041241"/>
       </p:ext>
     </p:extLst>
   </p:cSld>
@@ -3096,7 +3179,7 @@
           <a:lstStyle/>
           <a:p>
             <a:r>
-              <a:t>This is the direct check that the personal center helps the generator. Replacing it by a population center or another person’s center makes the feature distributions worse. We keep random draws and other inputs fixed, so the center is what changes. This supports useful information about this participant’s session. It does not give a name to each latent axis or show the same fingerprint would remain stable on another day. The control uses feature endpoints; we have not repeated it on the new full-trajectory endpoints. Source: frozen laboratory report section on personal fingerprints; course report Figure 3 and appendix A4. Bars show participant-balanced means after seed averaging. Markers compare each bar with the reference named above the chart, using the saved adjusted paired tests. In model-comparison charts, * means BH and Holm both pass .05; dagger means BH only; ns means neither. The personal-center chart uses its original BH-corrected control family. There are no error bars, and no p-value has been converted into an uncertainty interval.</a:t>
+              <a:t>This is the direct check that the personal center helps the generator. Replacing it by a population center or another person’s center makes the feature distributions worse. We keep random draws and other inputs fixed, so the center is what changes. This supports useful information about this participant’s session. It does not give a name to each latent axis or show the same fingerprint would remain stable on another day. The control uses feature endpoints; we have not repeated it on the new full-trajectory endpoints. Source: frozen laboratory report section on personal fingerprints; course report Figure 3 and appendix A4.</a:t>
             </a:r>
           </a:p>
           <a:p>
@@ -3128,7 +3211,7 @@
     </p:spTree>
     <p:extLst>
       <p:ext uri="{BB962C8B-B14F-4D97-AF65-F5344CB8AC3E}">
-        <p14:creationId xmlns:p14="http://schemas.microsoft.com/office/powerpoint/2010/main" val="2658059034"/>
+        <p14:creationId xmlns:p14="http://schemas.microsoft.com/office/powerpoint/2010/main" val="3225302393"/>
       </p:ext>
     </p:extLst>
   </p:cSld>
@@ -3744,7 +3827,7 @@
     </p:spTree>
     <p:extLst>
       <p:ext uri="{BB962C8B-B14F-4D97-AF65-F5344CB8AC3E}">
-        <p14:creationId xmlns:p14="http://schemas.microsoft.com/office/powerpoint/2010/main" val="1447141774"/>
+        <p14:creationId xmlns:p14="http://schemas.microsoft.com/office/powerpoint/2010/main" val="3899653625"/>
       </p:ext>
     </p:extLst>
   </p:cSld>
@@ -6574,10 +6657,10 @@
       </p:grpSpPr>
       <p:sp>
         <p:nvSpPr>
-          <p:cNvPr id="18" name="Rectangle 17">
+          <p:cNvPr id="17" name="Rectangle 16">
             <a:extLst>
               <a:ext uri="{FF2B5EF4-FFF2-40B4-BE49-F238E27FC236}">
-                <a16:creationId xmlns:a16="http://schemas.microsoft.com/office/drawing/2014/main" id="{C0DE50BB-B9F5-450F-A6E3-E9308770E70C}"/>
+                <a16:creationId xmlns:a16="http://schemas.microsoft.com/office/drawing/2014/main" id="{A408022B-7FD8-4C9E-8D2B-0A2A8498ADFC}"/>
               </a:ext>
             </a:extLst>
           </p:cNvPr>
@@ -6607,7 +6690,7 @@
           <p:cNvPr id="2" name="Rectangle 1">
             <a:extLst>
               <a:ext uri="{FF2B5EF4-FFF2-40B4-BE49-F238E27FC236}">
-                <a16:creationId xmlns:a16="http://schemas.microsoft.com/office/drawing/2014/main" id="{B6E6B16E-ED77-4D03-918F-7C6A677DEBED}"/>
+                <a16:creationId xmlns:a16="http://schemas.microsoft.com/office/drawing/2014/main" id="{99FC16E5-2EDB-481C-9F9F-6FD3DAC772CC}"/>
               </a:ext>
             </a:extLst>
           </p:cNvPr>
@@ -6637,7 +6720,7 @@
           <p:cNvPr id="3" name="Rectangle 2">
             <a:extLst>
               <a:ext uri="{FF2B5EF4-FFF2-40B4-BE49-F238E27FC236}">
-                <a16:creationId xmlns:a16="http://schemas.microsoft.com/office/drawing/2014/main" id="{DE79042C-3332-44D1-829E-7047018E579F}"/>
+                <a16:creationId xmlns:a16="http://schemas.microsoft.com/office/drawing/2014/main" id="{E0919766-3C0C-437F-B623-7D9A713DB73B}"/>
               </a:ext>
             </a:extLst>
           </p:cNvPr>
@@ -6667,7 +6750,7 @@
           <p:cNvPr id="4" name="Rectangle 3">
             <a:extLst>
               <a:ext uri="{FF2B5EF4-FFF2-40B4-BE49-F238E27FC236}">
-                <a16:creationId xmlns:a16="http://schemas.microsoft.com/office/drawing/2014/main" id="{49E6ED12-2DDB-4013-A795-720B55143A8A}"/>
+                <a16:creationId xmlns:a16="http://schemas.microsoft.com/office/drawing/2014/main" id="{56F968BF-F5B9-4BBD-8A02-31532F4FECCF}"/>
               </a:ext>
             </a:extLst>
           </p:cNvPr>
@@ -6724,7 +6807,7 @@
           <p:cNvPr id="5" name="Rectangle 4">
             <a:extLst>
               <a:ext uri="{FF2B5EF4-FFF2-40B4-BE49-F238E27FC236}">
-                <a16:creationId xmlns:a16="http://schemas.microsoft.com/office/drawing/2014/main" id="{4D4E7B43-A83C-4EB7-B81B-AB7A616076F5}"/>
+                <a16:creationId xmlns:a16="http://schemas.microsoft.com/office/drawing/2014/main" id="{E750F936-0108-4651-A364-6B8366B3697E}"/>
               </a:ext>
             </a:extLst>
           </p:cNvPr>
@@ -6771,7 +6854,7 @@
                 <a:ea typeface="Calibri"/>
                 <a:cs typeface="Calibri"/>
               </a:rPr>
-              <a:t>10/11</a:t>
+              <a:t>10</a:t>
             </a:r>
           </a:p>
         </p:txBody>
@@ -6781,7 +6864,7 @@
           <p:cNvPr id="6" name="Rectangle 5">
             <a:extLst>
               <a:ext uri="{FF2B5EF4-FFF2-40B4-BE49-F238E27FC236}">
-                <a16:creationId xmlns:a16="http://schemas.microsoft.com/office/drawing/2014/main" id="{BF1793ED-FD81-41E6-9B6F-392EE0687873}"/>
+                <a16:creationId xmlns:a16="http://schemas.microsoft.com/office/drawing/2014/main" id="{6B843479-F5AC-470F-8C18-576D5D788E7B}"/>
               </a:ext>
             </a:extLst>
           </p:cNvPr>
@@ -6811,7 +6894,7 @@
           <p:cNvPr id="7" name="Rectangle 6">
             <a:extLst>
               <a:ext uri="{FF2B5EF4-FFF2-40B4-BE49-F238E27FC236}">
-                <a16:creationId xmlns:a16="http://schemas.microsoft.com/office/drawing/2014/main" id="{E72FF379-FF9D-4E88-A68A-71AD8AC6C826}"/>
+                <a16:creationId xmlns:a16="http://schemas.microsoft.com/office/drawing/2014/main" id="{98370003-0ADD-4842-B2E5-FDF4E7131B08}"/>
               </a:ext>
             </a:extLst>
           </p:cNvPr>
@@ -6868,7 +6951,7 @@
           <p:cNvPr id="8" name="Rectangle 7">
             <a:extLst>
               <a:ext uri="{FF2B5EF4-FFF2-40B4-BE49-F238E27FC236}">
-                <a16:creationId xmlns:a16="http://schemas.microsoft.com/office/drawing/2014/main" id="{BCCC59F5-EC42-422F-8D09-8D337C9FF509}"/>
+                <a16:creationId xmlns:a16="http://schemas.microsoft.com/office/drawing/2014/main" id="{09DCDCE3-293C-446F-9052-36C4C08A95BF}"/>
               </a:ext>
             </a:extLst>
           </p:cNvPr>
@@ -6925,7 +7008,7 @@
           <p:cNvPr id="9" name="Rectangle 8">
             <a:extLst>
               <a:ext uri="{FF2B5EF4-FFF2-40B4-BE49-F238E27FC236}">
-                <a16:creationId xmlns:a16="http://schemas.microsoft.com/office/drawing/2014/main" id="{CBA9E78C-7FA3-4DB4-9A34-570B2A47FE34}"/>
+                <a16:creationId xmlns:a16="http://schemas.microsoft.com/office/drawing/2014/main" id="{6ABC9805-0D2F-48E7-A7B4-15613DAC9054}"/>
               </a:ext>
             </a:extLst>
           </p:cNvPr>
@@ -6982,7 +7065,7 @@
           <p:cNvPr id="10" name="Rectangle 9">
             <a:extLst>
               <a:ext uri="{FF2B5EF4-FFF2-40B4-BE49-F238E27FC236}">
-                <a16:creationId xmlns:a16="http://schemas.microsoft.com/office/drawing/2014/main" id="{2FC0FF50-8BC3-42EA-85E0-A83B41126EB5}"/>
+                <a16:creationId xmlns:a16="http://schemas.microsoft.com/office/drawing/2014/main" id="{A063DAAB-78AA-429A-8EB4-D3023F4571EE}"/>
               </a:ext>
             </a:extLst>
           </p:cNvPr>
@@ -7062,7 +7145,7 @@
           <p:cNvPr id="11" name="Rectangle 10">
             <a:extLst>
               <a:ext uri="{FF2B5EF4-FFF2-40B4-BE49-F238E27FC236}">
-                <a16:creationId xmlns:a16="http://schemas.microsoft.com/office/drawing/2014/main" id="{C2A79F62-0E84-4E8C-B977-2A74C7B8411C}"/>
+                <a16:creationId xmlns:a16="http://schemas.microsoft.com/office/drawing/2014/main" id="{12AEB5B8-CD72-4E1E-AE1D-D0F95B0CC0EE}"/>
               </a:ext>
             </a:extLst>
           </p:cNvPr>
@@ -7116,7 +7199,7 @@
       </p:sp>
       <p:graphicFrame>
         <p:nvGraphicFramePr>
-          <p:cNvPr id="29" name="Chart"/>
+          <p:cNvPr id="28" name="Chart"/>
           <p:cNvGraphicFramePr/>
           <p:nvPr/>
         </p:nvGraphicFramePr>
@@ -7135,7 +7218,7 @@
           <p:cNvPr id="13" name="Rectangle 12">
             <a:extLst>
               <a:ext uri="{FF2B5EF4-FFF2-40B4-BE49-F238E27FC236}">
-                <a16:creationId xmlns:a16="http://schemas.microsoft.com/office/drawing/2014/main" id="{E13976B6-16B3-4E7B-B250-7E34EB86548F}"/>
+                <a16:creationId xmlns:a16="http://schemas.microsoft.com/office/drawing/2014/main" id="{D0ED6F97-1A81-4F70-8A9B-9FF69427E5C1}"/>
               </a:ext>
             </a:extLst>
           </p:cNvPr>
@@ -7146,53 +7229,26 @@
         </p:nvSpPr>
         <p:spPr>
           <a:xfrm>
-            <a:off x="4438650" y="5048250"/>
-            <a:ext cx="6972300" cy="257175"/>
-          </a:xfrm>
-          <a:prstGeom prst="rect">
-            <a:avLst/>
-          </a:prstGeom>
-          <a:noFill/>
+            <a:off x="781050" y="5457825"/>
+            <a:ext cx="10629900" cy="1104900"/>
+          </a:xfrm>
+          <a:prstGeom prst="rect">
+            <a:avLst/>
+          </a:prstGeom>
+          <a:solidFill>
+            <a:srgbClr val="EFF5FC"/>
+          </a:solidFill>
           <a:ln w="0">
             <a:noFill/>
           </a:ln>
         </p:spPr>
-        <p:txBody>
-          <a:bodyPr>
-            <a:noAutofit/>
-          </a:bodyPr>
-          <a:lstStyle/>
-          <a:p>
-            <a:pPr>
-              <a:defRPr sz="1350" b="0">
-                <a:solidFill>
-                  <a:srgbClr val="596678"/>
-                </a:solidFill>
-                <a:latin typeface="Calibri"/>
-                <a:ea typeface="Calibri"/>
-                <a:cs typeface="Calibri"/>
-              </a:defRPr>
-            </a:pPr>
-            <a:r>
-              <a:rPr sz="1350" b="0">
-                <a:solidFill>
-                  <a:srgbClr val="596678"/>
-                </a:solidFill>
-                <a:latin typeface="Calibri"/>
-                <a:ea typeface="Calibri"/>
-                <a:cs typeface="Calibri"/>
-              </a:rPr>
-              <a:t>* Different from own center: BH-adjusted p &lt; .05</a:t>
-            </a:r>
-          </a:p>
-        </p:txBody>
       </p:sp>
       <p:sp>
         <p:nvSpPr>
           <p:cNvPr id="14" name="Rectangle 13">
             <a:extLst>
               <a:ext uri="{FF2B5EF4-FFF2-40B4-BE49-F238E27FC236}">
-                <a16:creationId xmlns:a16="http://schemas.microsoft.com/office/drawing/2014/main" id="{9D14345A-58D6-480E-AB61-A4EE5C1A3F12}"/>
+                <a16:creationId xmlns:a16="http://schemas.microsoft.com/office/drawing/2014/main" id="{67CB7DF8-9CAC-476A-A210-C942E4E5791E}"/>
               </a:ext>
             </a:extLst>
           </p:cNvPr>
@@ -7204,36 +7260,6 @@
         <p:spPr>
           <a:xfrm>
             <a:off x="781050" y="5457825"/>
-            <a:ext cx="10629900" cy="1104900"/>
-          </a:xfrm>
-          <a:prstGeom prst="rect">
-            <a:avLst/>
-          </a:prstGeom>
-          <a:solidFill>
-            <a:srgbClr val="EFF5FC"/>
-          </a:solidFill>
-          <a:ln w="0">
-            <a:noFill/>
-          </a:ln>
-        </p:spPr>
-      </p:sp>
-      <p:sp>
-        <p:nvSpPr>
-          <p:cNvPr id="15" name="Rectangle 14">
-            <a:extLst>
-              <a:ext uri="{FF2B5EF4-FFF2-40B4-BE49-F238E27FC236}">
-                <a16:creationId xmlns:a16="http://schemas.microsoft.com/office/drawing/2014/main" id="{2239D09D-277B-4DFD-BC35-5397B83CCE60}"/>
-              </a:ext>
-            </a:extLst>
-          </p:cNvPr>
-          <p:cNvSpPr>
-            <a:spLocks noGrp="1"/>
-          </p:cNvSpPr>
-          <p:nvPr/>
-        </p:nvSpPr>
-        <p:spPr>
-          <a:xfrm>
-            <a:off x="781050" y="5457825"/>
             <a:ext cx="47625" cy="1104900"/>
           </a:xfrm>
           <a:prstGeom prst="rect">
@@ -7249,10 +7275,10 @@
       </p:sp>
       <p:sp>
         <p:nvSpPr>
-          <p:cNvPr id="16" name="Rectangle 15">
+          <p:cNvPr id="15" name="Rectangle 14">
             <a:extLst>
               <a:ext uri="{FF2B5EF4-FFF2-40B4-BE49-F238E27FC236}">
-                <a16:creationId xmlns:a16="http://schemas.microsoft.com/office/drawing/2014/main" id="{9FFF70DA-DC06-4E80-B2A4-4377FBB57A29}"/>
+                <a16:creationId xmlns:a16="http://schemas.microsoft.com/office/drawing/2014/main" id="{5FB6C5D5-88F1-4FA5-975A-1B098530BB0D}"/>
               </a:ext>
             </a:extLst>
           </p:cNvPr>
@@ -7306,10 +7332,10 @@
       </p:sp>
       <p:sp>
         <p:nvSpPr>
-          <p:cNvPr id="17" name="Rectangle 16">
+          <p:cNvPr id="16" name="Rectangle 15">
             <a:extLst>
               <a:ext uri="{FF2B5EF4-FFF2-40B4-BE49-F238E27FC236}">
-                <a16:creationId xmlns:a16="http://schemas.microsoft.com/office/drawing/2014/main" id="{D693DA89-324B-4504-B0E8-1BE491069221}"/>
+                <a16:creationId xmlns:a16="http://schemas.microsoft.com/office/drawing/2014/main" id="{74503C0F-C319-450C-BA6D-0E12F37183EB}"/>
               </a:ext>
             </a:extLst>
           </p:cNvPr>
@@ -7356,7 +7382,7 @@
                 <a:ea typeface="Calibri"/>
                 <a:cs typeface="Calibri"/>
               </a:rPr>
-              <a:t>Both n=8 models improve on population and other-person centers. This supports useful personal information within the session.</a:t>
+              <a:t>Both n=8 models beat population and other-person centers (BH-adjusted p &lt; .05): useful personal information within the session.</a:t>
             </a:r>
           </a:p>
         </p:txBody>
@@ -7364,7 +7390,7 @@
     </p:spTree>
     <p:extLst>
       <p:ext uri="{BB962C8B-B14F-4D97-AF65-F5344CB8AC3E}">
-        <p14:creationId xmlns:p14="http://schemas.microsoft.com/office/powerpoint/2010/main" val="928960201"/>
+        <p14:creationId xmlns:p14="http://schemas.microsoft.com/office/powerpoint/2010/main" val="474420200"/>
       </p:ext>
     </p:extLst>
   </p:cSld>
@@ -7396,7 +7422,7 @@
           <p:cNvPr id="9" name="Rectangle 8">
             <a:extLst>
               <a:ext uri="{FF2B5EF4-FFF2-40B4-BE49-F238E27FC236}">
-                <a16:creationId xmlns:a16="http://schemas.microsoft.com/office/drawing/2014/main" id="{36A49027-6E27-48FF-BA8D-ECDE2BBF2BBF}"/>
+                <a16:creationId xmlns:a16="http://schemas.microsoft.com/office/drawing/2014/main" id="{2472973F-5C5F-4667-BE66-47511C7C0941}"/>
               </a:ext>
             </a:extLst>
           </p:cNvPr>
@@ -7426,7 +7452,7 @@
           <p:cNvPr id="2" name="Rectangle 1">
             <a:extLst>
               <a:ext uri="{FF2B5EF4-FFF2-40B4-BE49-F238E27FC236}">
-                <a16:creationId xmlns:a16="http://schemas.microsoft.com/office/drawing/2014/main" id="{094156C9-6827-44C3-BB82-5B729713A0DD}"/>
+                <a16:creationId xmlns:a16="http://schemas.microsoft.com/office/drawing/2014/main" id="{A39A65FF-BF34-4A7B-BBEE-9F1AF44F3E25}"/>
               </a:ext>
             </a:extLst>
           </p:cNvPr>
@@ -7456,7 +7482,7 @@
           <p:cNvPr id="3" name="Rectangle 2">
             <a:extLst>
               <a:ext uri="{FF2B5EF4-FFF2-40B4-BE49-F238E27FC236}">
-                <a16:creationId xmlns:a16="http://schemas.microsoft.com/office/drawing/2014/main" id="{A18FEAAE-5BCD-4401-8B6D-AA0449DCF231}"/>
+                <a16:creationId xmlns:a16="http://schemas.microsoft.com/office/drawing/2014/main" id="{72A54756-A051-4B62-99CD-489C1B2B3116}"/>
               </a:ext>
             </a:extLst>
           </p:cNvPr>
@@ -7486,7 +7512,7 @@
           <p:cNvPr id="4" name="Rectangle 3">
             <a:extLst>
               <a:ext uri="{FF2B5EF4-FFF2-40B4-BE49-F238E27FC236}">
-                <a16:creationId xmlns:a16="http://schemas.microsoft.com/office/drawing/2014/main" id="{8499A35A-A4B3-4269-9209-EFCFE1256449}"/>
+                <a16:creationId xmlns:a16="http://schemas.microsoft.com/office/drawing/2014/main" id="{FA929D1B-1CD7-4F10-BEC1-C0D155F4048F}"/>
               </a:ext>
             </a:extLst>
           </p:cNvPr>
@@ -7543,7 +7569,7 @@
           <p:cNvPr id="5" name="Rectangle 4">
             <a:extLst>
               <a:ext uri="{FF2B5EF4-FFF2-40B4-BE49-F238E27FC236}">
-                <a16:creationId xmlns:a16="http://schemas.microsoft.com/office/drawing/2014/main" id="{D82828C6-C863-4821-B7AE-4CC6612D4A36}"/>
+                <a16:creationId xmlns:a16="http://schemas.microsoft.com/office/drawing/2014/main" id="{90C5E0A7-C4D9-4486-8EC2-B01DD6CAE37A}"/>
               </a:ext>
             </a:extLst>
           </p:cNvPr>
@@ -7590,7 +7616,7 @@
                 <a:ea typeface="Calibri"/>
                 <a:cs typeface="Calibri"/>
               </a:rPr>
-              <a:t>11/11</a:t>
+              <a:t>11</a:t>
             </a:r>
           </a:p>
         </p:txBody>
@@ -7600,7 +7626,7 @@
           <p:cNvPr id="6" name="Rectangle 5">
             <a:extLst>
               <a:ext uri="{FF2B5EF4-FFF2-40B4-BE49-F238E27FC236}">
-                <a16:creationId xmlns:a16="http://schemas.microsoft.com/office/drawing/2014/main" id="{70970964-1830-497A-9147-5802830EB1C0}"/>
+                <a16:creationId xmlns:a16="http://schemas.microsoft.com/office/drawing/2014/main" id="{B682C638-46C8-4B66-B590-0DCC5352301B}"/>
               </a:ext>
             </a:extLst>
           </p:cNvPr>
@@ -7630,7 +7656,7 @@
           <p:cNvPr id="7" name="Rectangle 6">
             <a:extLst>
               <a:ext uri="{FF2B5EF4-FFF2-40B4-BE49-F238E27FC236}">
-                <a16:creationId xmlns:a16="http://schemas.microsoft.com/office/drawing/2014/main" id="{98F51E34-6A42-4CA4-8DE0-B8076A2CDAC2}"/>
+                <a16:creationId xmlns:a16="http://schemas.microsoft.com/office/drawing/2014/main" id="{57AD7950-12F8-4DB9-BD64-65C4DFC77E1F}"/>
               </a:ext>
             </a:extLst>
           </p:cNvPr>
@@ -7707,7 +7733,306 @@
     </p:spTree>
     <p:extLst>
       <p:ext uri="{BB962C8B-B14F-4D97-AF65-F5344CB8AC3E}">
-        <p14:creationId xmlns:p14="http://schemas.microsoft.com/office/powerpoint/2010/main" val="3669060647"/>
+        <p14:creationId xmlns:p14="http://schemas.microsoft.com/office/powerpoint/2010/main" val="2906170075"/>
+      </p:ext>
+    </p:extLst>
+  </p:cSld>
+  <p:clrMapOvr>
+    <a:masterClrMapping/>
+  </p:clrMapOvr>
+</p:sld>
+</file>
+
+<file path=ppt/slides/slide12.xml><?xml version="1.0" encoding="utf-8"?>
+<p:sld xmlns:a="http://schemas.openxmlformats.org/drawingml/2006/main" xmlns:r="http://schemas.openxmlformats.org/officeDocument/2006/relationships" xmlns:p="http://schemas.openxmlformats.org/presentationml/2006/main">
+  <p:cSld>
+    <p:bg>
+      <p:bgPr>
+        <a:solidFill>
+          <a:srgbClr val="0E1729"/>
+        </a:solidFill>
+        <a:effectLst/>
+      </p:bgPr>
+    </p:bg>
+    <p:spTree>
+      <p:nvGrpSpPr>
+        <p:cNvPr id="1" name=""/>
+        <p:cNvGrpSpPr/>
+        <p:nvPr/>
+      </p:nvGrpSpPr>
+      <p:grpSpPr>
+        <a:xfrm>
+          <a:off x="0" y="0"/>
+          <a:ext cx="0" cy="0"/>
+          <a:chOff x="0" y="0"/>
+          <a:chExt cx="0" cy="0"/>
+        </a:xfrm>
+      </p:grpSpPr>
+      <p:sp>
+        <p:nvSpPr>
+          <p:cNvPr id="7" name="Rectangle 6">
+            <a:extLst>
+              <a:ext uri="{FF2B5EF4-FFF2-40B4-BE49-F238E27FC236}">
+                <a16:creationId xmlns:a16="http://schemas.microsoft.com/office/drawing/2014/main" id="{8DF802DF-035A-481E-9DF1-CD3762CD6509}"/>
+              </a:ext>
+            </a:extLst>
+          </p:cNvPr>
+          <p:cNvSpPr>
+            <a:spLocks noGrp="1"/>
+          </p:cNvSpPr>
+          <p:nvPr/>
+        </p:nvSpPr>
+        <p:spPr>
+          <a:xfrm>
+            <a:off x="0" y="0"/>
+            <a:ext cx="4063898" cy="66675"/>
+          </a:xfrm>
+          <a:prstGeom prst="rect">
+            <a:avLst/>
+          </a:prstGeom>
+          <a:solidFill>
+            <a:srgbClr val="1B6FEA"/>
+          </a:solidFill>
+          <a:ln w="0">
+            <a:noFill/>
+          </a:ln>
+        </p:spPr>
+      </p:sp>
+      <p:sp>
+        <p:nvSpPr>
+          <p:cNvPr id="2" name="Rectangle 1">
+            <a:extLst>
+              <a:ext uri="{FF2B5EF4-FFF2-40B4-BE49-F238E27FC236}">
+                <a16:creationId xmlns:a16="http://schemas.microsoft.com/office/drawing/2014/main" id="{D054EFC5-3C86-49E9-B5C6-80F60A78CA85}"/>
+              </a:ext>
+            </a:extLst>
+          </p:cNvPr>
+          <p:cNvSpPr>
+            <a:spLocks noGrp="1"/>
+          </p:cNvSpPr>
+          <p:nvPr/>
+        </p:nvSpPr>
+        <p:spPr>
+          <a:xfrm>
+            <a:off x="4063898" y="0"/>
+            <a:ext cx="4063898" cy="66675"/>
+          </a:xfrm>
+          <a:prstGeom prst="rect">
+            <a:avLst/>
+          </a:prstGeom>
+          <a:solidFill>
+            <a:srgbClr val="17A2A2"/>
+          </a:solidFill>
+          <a:ln w="0">
+            <a:noFill/>
+          </a:ln>
+        </p:spPr>
+      </p:sp>
+      <p:sp>
+        <p:nvSpPr>
+          <p:cNvPr id="3" name="Rectangle 2">
+            <a:extLst>
+              <a:ext uri="{FF2B5EF4-FFF2-40B4-BE49-F238E27FC236}">
+                <a16:creationId xmlns:a16="http://schemas.microsoft.com/office/drawing/2014/main" id="{CA55B66F-BF02-407F-B351-19EB8F4AB422}"/>
+              </a:ext>
+            </a:extLst>
+          </p:cNvPr>
+          <p:cNvSpPr>
+            <a:spLocks noGrp="1"/>
+          </p:cNvSpPr>
+          <p:nvPr/>
+        </p:nvSpPr>
+        <p:spPr>
+          <a:xfrm>
+            <a:off x="8127797" y="0"/>
+            <a:ext cx="4063898" cy="66675"/>
+          </a:xfrm>
+          <a:prstGeom prst="rect">
+            <a:avLst/>
+          </a:prstGeom>
+          <a:solidFill>
+            <a:srgbClr val="7A5CF0"/>
+          </a:solidFill>
+          <a:ln w="0">
+            <a:noFill/>
+          </a:ln>
+        </p:spPr>
+      </p:sp>
+      <p:sp>
+        <p:nvSpPr>
+          <p:cNvPr id="4" name="Rectangle 3">
+            <a:extLst>
+              <a:ext uri="{FF2B5EF4-FFF2-40B4-BE49-F238E27FC236}">
+                <a16:creationId xmlns:a16="http://schemas.microsoft.com/office/drawing/2014/main" id="{5549A944-1D58-4F12-A841-43AB07F22A3D}"/>
+              </a:ext>
+            </a:extLst>
+          </p:cNvPr>
+          <p:cNvSpPr>
+            <a:spLocks noGrp="1"/>
+          </p:cNvSpPr>
+          <p:nvPr/>
+        </p:nvSpPr>
+        <p:spPr>
+          <a:xfrm>
+            <a:off x="781050" y="2143125"/>
+            <a:ext cx="10629900" cy="904875"/>
+          </a:xfrm>
+          <a:prstGeom prst="rect">
+            <a:avLst/>
+          </a:prstGeom>
+          <a:noFill/>
+          <a:ln w="0">
+            <a:noFill/>
+          </a:ln>
+        </p:spPr>
+        <p:txBody>
+          <a:bodyPr>
+            <a:noAutofit/>
+          </a:bodyPr>
+          <a:lstStyle/>
+          <a:p>
+            <a:pPr algn="ctr">
+              <a:defRPr sz="5100" b="1">
+                <a:solidFill>
+                  <a:srgbClr val="FFFFFF"/>
+                </a:solidFill>
+                <a:latin typeface="Calibri"/>
+                <a:ea typeface="Calibri"/>
+                <a:cs typeface="Calibri"/>
+              </a:defRPr>
+            </a:pPr>
+            <a:r>
+              <a:rPr sz="5100" b="1">
+                <a:solidFill>
+                  <a:srgbClr val="FFFFFF"/>
+                </a:solidFill>
+                <a:latin typeface="Calibri"/>
+                <a:ea typeface="Calibri"/>
+                <a:cs typeface="Calibri"/>
+              </a:rPr>
+              <a:t>Thank you</a:t>
+            </a:r>
+          </a:p>
+        </p:txBody>
+      </p:sp>
+      <p:sp>
+        <p:nvSpPr>
+          <p:cNvPr id="5" name="Rectangle 4">
+            <a:extLst>
+              <a:ext uri="{FF2B5EF4-FFF2-40B4-BE49-F238E27FC236}">
+                <a16:creationId xmlns:a16="http://schemas.microsoft.com/office/drawing/2014/main" id="{F675F847-7FA4-4916-B65A-56BE39390C9A}"/>
+              </a:ext>
+            </a:extLst>
+          </p:cNvPr>
+          <p:cNvSpPr>
+            <a:spLocks noGrp="1"/>
+          </p:cNvSpPr>
+          <p:nvPr/>
+        </p:nvSpPr>
+        <p:spPr>
+          <a:xfrm>
+            <a:off x="781050" y="3190875"/>
+            <a:ext cx="10629900" cy="685800"/>
+          </a:xfrm>
+          <a:prstGeom prst="rect">
+            <a:avLst/>
+          </a:prstGeom>
+          <a:noFill/>
+          <a:ln w="0">
+            <a:noFill/>
+          </a:ln>
+        </p:spPr>
+        <p:txBody>
+          <a:bodyPr>
+            <a:noAutofit/>
+          </a:bodyPr>
+          <a:lstStyle/>
+          <a:p>
+            <a:pPr algn="ctr">
+              <a:defRPr sz="3300" b="1">
+                <a:solidFill>
+                  <a:srgbClr val="3EB1EC"/>
+                </a:solidFill>
+                <a:latin typeface="Calibri"/>
+                <a:ea typeface="Calibri"/>
+                <a:cs typeface="Calibri"/>
+              </a:defRPr>
+            </a:pPr>
+            <a:r>
+              <a:rPr sz="3300" b="1">
+                <a:solidFill>
+                  <a:srgbClr val="3EB1EC"/>
+                </a:solidFill>
+                <a:latin typeface="Calibri"/>
+                <a:ea typeface="Calibri"/>
+                <a:cs typeface="Calibri"/>
+              </a:rPr>
+              <a:t>Questions?</a:t>
+            </a:r>
+          </a:p>
+        </p:txBody>
+      </p:sp>
+      <p:sp>
+        <p:nvSpPr>
+          <p:cNvPr id="6" name="Rectangle 5">
+            <a:extLst>
+              <a:ext uri="{FF2B5EF4-FFF2-40B4-BE49-F238E27FC236}">
+                <a16:creationId xmlns:a16="http://schemas.microsoft.com/office/drawing/2014/main" id="{6DCC65A0-61E3-4101-B10C-CB6E199889D4}"/>
+              </a:ext>
+            </a:extLst>
+          </p:cNvPr>
+          <p:cNvSpPr>
+            <a:spLocks noGrp="1"/>
+          </p:cNvSpPr>
+          <p:nvPr/>
+        </p:nvSpPr>
+        <p:spPr>
+          <a:xfrm>
+            <a:off x="781050" y="4667250"/>
+            <a:ext cx="10629900" cy="495300"/>
+          </a:xfrm>
+          <a:prstGeom prst="rect">
+            <a:avLst/>
+          </a:prstGeom>
+          <a:noFill/>
+          <a:ln w="0">
+            <a:noFill/>
+          </a:ln>
+        </p:spPr>
+        <p:txBody>
+          <a:bodyPr>
+            <a:noAutofit/>
+          </a:bodyPr>
+          <a:lstStyle/>
+          <a:p>
+            <a:pPr algn="ctr">
+              <a:defRPr sz="2175" b="1">
+                <a:solidFill>
+                  <a:srgbClr val="A3B2C6"/>
+                </a:solidFill>
+                <a:latin typeface="Calibri"/>
+                <a:ea typeface="Calibri"/>
+                <a:cs typeface="Calibri"/>
+              </a:defRPr>
+            </a:pPr>
+            <a:r>
+              <a:rPr sz="2175" b="1">
+                <a:solidFill>
+                  <a:srgbClr val="A3B2C6"/>
+                </a:solidFill>
+                <a:latin typeface="Calibri"/>
+                <a:ea typeface="Calibri"/>
+                <a:cs typeface="Calibri"/>
+              </a:rPr>
+              <a:t>Seman Libbiss &amp; Paz Flashner</a:t>
+            </a:r>
+          </a:p>
+        </p:txBody>
+      </p:sp>
+    </p:spTree>
+    <p:extLst>
+      <p:ext uri="{BB962C8B-B14F-4D97-AF65-F5344CB8AC3E}">
+        <p14:creationId xmlns:p14="http://schemas.microsoft.com/office/powerpoint/2010/main" val="4221034681"/>
       </p:ext>
     </p:extLst>
   </p:cSld>
@@ -13559,10 +13884,10 @@
       </p:grpSpPr>
       <p:sp>
         <p:nvSpPr>
-          <p:cNvPr id="18" name="Rectangle 17">
+          <p:cNvPr id="17" name="Rectangle 16">
             <a:extLst>
               <a:ext uri="{FF2B5EF4-FFF2-40B4-BE49-F238E27FC236}">
-                <a16:creationId xmlns:a16="http://schemas.microsoft.com/office/drawing/2014/main" id="{054D93EC-A010-4717-AA23-C14748487246}"/>
+                <a16:creationId xmlns:a16="http://schemas.microsoft.com/office/drawing/2014/main" id="{35E9D57E-27D2-452C-9EE8-57A385EAFA8F}"/>
               </a:ext>
             </a:extLst>
           </p:cNvPr>
@@ -13592,7 +13917,7 @@
           <p:cNvPr id="2" name="Rectangle 1">
             <a:extLst>
               <a:ext uri="{FF2B5EF4-FFF2-40B4-BE49-F238E27FC236}">
-                <a16:creationId xmlns:a16="http://schemas.microsoft.com/office/drawing/2014/main" id="{5F2600DB-8581-4BF9-904E-FBB0CE7603C0}"/>
+                <a16:creationId xmlns:a16="http://schemas.microsoft.com/office/drawing/2014/main" id="{AC42E77C-D097-4786-B3F0-A8F42CD4D4FE}"/>
               </a:ext>
             </a:extLst>
           </p:cNvPr>
@@ -13622,7 +13947,7 @@
           <p:cNvPr id="3" name="Rectangle 2">
             <a:extLst>
               <a:ext uri="{FF2B5EF4-FFF2-40B4-BE49-F238E27FC236}">
-                <a16:creationId xmlns:a16="http://schemas.microsoft.com/office/drawing/2014/main" id="{A5D82DC8-2126-4B27-B3D2-E488912D7A47}"/>
+                <a16:creationId xmlns:a16="http://schemas.microsoft.com/office/drawing/2014/main" id="{BC197BFE-D5C0-48A5-8E30-8AA43C13BEA8}"/>
               </a:ext>
             </a:extLst>
           </p:cNvPr>
@@ -13652,7 +13977,7 @@
           <p:cNvPr id="4" name="Rectangle 3">
             <a:extLst>
               <a:ext uri="{FF2B5EF4-FFF2-40B4-BE49-F238E27FC236}">
-                <a16:creationId xmlns:a16="http://schemas.microsoft.com/office/drawing/2014/main" id="{FCE86577-5890-4869-8FCF-792268169B8B}"/>
+                <a16:creationId xmlns:a16="http://schemas.microsoft.com/office/drawing/2014/main" id="{6DD15928-FCBE-413E-A101-291D00C0657F}"/>
               </a:ext>
             </a:extLst>
           </p:cNvPr>
@@ -13709,7 +14034,7 @@
           <p:cNvPr id="5" name="Rectangle 4">
             <a:extLst>
               <a:ext uri="{FF2B5EF4-FFF2-40B4-BE49-F238E27FC236}">
-                <a16:creationId xmlns:a16="http://schemas.microsoft.com/office/drawing/2014/main" id="{C654E9D0-6CFF-463B-AD1E-26CD60EADDFF}"/>
+                <a16:creationId xmlns:a16="http://schemas.microsoft.com/office/drawing/2014/main" id="{24F2C61D-EB2E-4811-AADB-72E15F3986FA}"/>
               </a:ext>
             </a:extLst>
           </p:cNvPr>
@@ -13756,7 +14081,7 @@
                 <a:ea typeface="Calibri"/>
                 <a:cs typeface="Calibri"/>
               </a:rPr>
-              <a:t>9/11</a:t>
+              <a:t>9</a:t>
             </a:r>
           </a:p>
         </p:txBody>
@@ -13766,7 +14091,7 @@
           <p:cNvPr id="6" name="Rectangle 5">
             <a:extLst>
               <a:ext uri="{FF2B5EF4-FFF2-40B4-BE49-F238E27FC236}">
-                <a16:creationId xmlns:a16="http://schemas.microsoft.com/office/drawing/2014/main" id="{9ABD4985-3D64-4EF7-9066-BE735F274DC9}"/>
+                <a16:creationId xmlns:a16="http://schemas.microsoft.com/office/drawing/2014/main" id="{6E4A26D4-C28D-46B3-9E13-6651D8145A8F}"/>
               </a:ext>
             </a:extLst>
           </p:cNvPr>
@@ -13796,7 +14121,7 @@
           <p:cNvPr id="7" name="Rectangle 6">
             <a:extLst>
               <a:ext uri="{FF2B5EF4-FFF2-40B4-BE49-F238E27FC236}">
-                <a16:creationId xmlns:a16="http://schemas.microsoft.com/office/drawing/2014/main" id="{BD6D3B59-0C90-4EFB-B945-E54C76DC8F6A}"/>
+                <a16:creationId xmlns:a16="http://schemas.microsoft.com/office/drawing/2014/main" id="{2D024193-040B-461A-9D97-B6EA179102D3}"/>
               </a:ext>
             </a:extLst>
           </p:cNvPr>
@@ -13853,7 +14178,7 @@
           <p:cNvPr id="8" name="Rectangle 7">
             <a:extLst>
               <a:ext uri="{FF2B5EF4-FFF2-40B4-BE49-F238E27FC236}">
-                <a16:creationId xmlns:a16="http://schemas.microsoft.com/office/drawing/2014/main" id="{EC9D903F-F2A8-47EE-8647-4EA1B6791697}"/>
+                <a16:creationId xmlns:a16="http://schemas.microsoft.com/office/drawing/2014/main" id="{9FF07C1D-AF30-4EE6-B909-0E96A9F41891}"/>
               </a:ext>
             </a:extLst>
           </p:cNvPr>
@@ -13910,7 +14235,7 @@
           <p:cNvPr id="9" name="Rectangle 8">
             <a:extLst>
               <a:ext uri="{FF2B5EF4-FFF2-40B4-BE49-F238E27FC236}">
-                <a16:creationId xmlns:a16="http://schemas.microsoft.com/office/drawing/2014/main" id="{E5FCD7DA-9670-4500-8E1D-1B05AB3745BB}"/>
+                <a16:creationId xmlns:a16="http://schemas.microsoft.com/office/drawing/2014/main" id="{809263EA-DDDF-4609-AA1F-87BEF2C0F26B}"/>
               </a:ext>
             </a:extLst>
           </p:cNvPr>
@@ -13964,7 +14289,7 @@
       </p:sp>
       <p:graphicFrame>
         <p:nvGraphicFramePr>
-          <p:cNvPr id="27" name="Chart"/>
+          <p:cNvPr id="26" name="Chart"/>
           <p:cNvGraphicFramePr/>
           <p:nvPr/>
         </p:nvGraphicFramePr>
@@ -13983,7 +14308,7 @@
           <p:cNvPr id="11" name="Rectangle 10">
             <a:extLst>
               <a:ext uri="{FF2B5EF4-FFF2-40B4-BE49-F238E27FC236}">
-                <a16:creationId xmlns:a16="http://schemas.microsoft.com/office/drawing/2014/main" id="{D0D2392C-A223-4AF7-8149-99237670728C}"/>
+                <a16:creationId xmlns:a16="http://schemas.microsoft.com/office/drawing/2014/main" id="{0CDB51AC-9F8C-497B-B1DF-3B6AF147EBA7}"/>
               </a:ext>
             </a:extLst>
           </p:cNvPr>
@@ -14037,7 +14362,7 @@
       </p:sp>
       <p:graphicFrame>
         <p:nvGraphicFramePr>
-          <p:cNvPr id="29" name="Chart"/>
+          <p:cNvPr id="28" name="Chart"/>
           <p:cNvGraphicFramePr/>
           <p:nvPr/>
         </p:nvGraphicFramePr>
@@ -14056,7 +14381,7 @@
           <p:cNvPr id="13" name="Rectangle 12">
             <a:extLst>
               <a:ext uri="{FF2B5EF4-FFF2-40B4-BE49-F238E27FC236}">
-                <a16:creationId xmlns:a16="http://schemas.microsoft.com/office/drawing/2014/main" id="{A6D32E7B-C1A4-40D0-A668-481B811E6EA1}"/>
+                <a16:creationId xmlns:a16="http://schemas.microsoft.com/office/drawing/2014/main" id="{89A446EE-1D46-411B-BF61-C42507059E28}"/>
               </a:ext>
             </a:extLst>
           </p:cNvPr>
@@ -14067,53 +14392,26 @@
         </p:nvSpPr>
         <p:spPr>
           <a:xfrm>
-            <a:off x="781050" y="5048250"/>
-            <a:ext cx="10629900" cy="257175"/>
-          </a:xfrm>
-          <a:prstGeom prst="rect">
-            <a:avLst/>
-          </a:prstGeom>
-          <a:noFill/>
+            <a:off x="781050" y="5457825"/>
+            <a:ext cx="10629900" cy="1104900"/>
+          </a:xfrm>
+          <a:prstGeom prst="rect">
+            <a:avLst/>
+          </a:prstGeom>
+          <a:solidFill>
+            <a:srgbClr val="EFF5FC"/>
+          </a:solidFill>
           <a:ln w="0">
             <a:noFill/>
           </a:ln>
         </p:spPr>
-        <p:txBody>
-          <a:bodyPr>
-            <a:noAutofit/>
-          </a:bodyPr>
-          <a:lstStyle/>
-          <a:p>
-            <a:pPr>
-              <a:defRPr sz="1275" b="0">
-                <a:solidFill>
-                  <a:srgbClr val="596678"/>
-                </a:solidFill>
-                <a:latin typeface="Calibri"/>
-                <a:ea typeface="Calibri"/>
-                <a:cs typeface="Calibri"/>
-              </a:defRPr>
-            </a:pPr>
-            <a:r>
-              <a:rPr sz="1275" b="0">
-                <a:solidFill>
-                  <a:srgbClr val="596678"/>
-                </a:solidFill>
-                <a:latin typeface="Calibri"/>
-                <a:ea typeface="Calibri"/>
-                <a:cs typeface="Calibri"/>
-              </a:rPr>
-              <a:t>Vs spline, same n:  * BH + Holm &lt; .05     † BH only     ns neither  |  28 participants; paired tests, 80 comparisons</a:t>
-            </a:r>
-          </a:p>
-        </p:txBody>
       </p:sp>
       <p:sp>
         <p:nvSpPr>
           <p:cNvPr id="14" name="Rectangle 13">
             <a:extLst>
               <a:ext uri="{FF2B5EF4-FFF2-40B4-BE49-F238E27FC236}">
-                <a16:creationId xmlns:a16="http://schemas.microsoft.com/office/drawing/2014/main" id="{515FA8F8-1D86-4AA0-BFAC-B5BEA94B73CB}"/>
+                <a16:creationId xmlns:a16="http://schemas.microsoft.com/office/drawing/2014/main" id="{FB819AA4-740E-440A-8ABE-0E2E7119D06A}"/>
               </a:ext>
             </a:extLst>
           </p:cNvPr>
@@ -14125,36 +14423,6 @@
         <p:spPr>
           <a:xfrm>
             <a:off x="781050" y="5457825"/>
-            <a:ext cx="10629900" cy="1104900"/>
-          </a:xfrm>
-          <a:prstGeom prst="rect">
-            <a:avLst/>
-          </a:prstGeom>
-          <a:solidFill>
-            <a:srgbClr val="EFF5FC"/>
-          </a:solidFill>
-          <a:ln w="0">
-            <a:noFill/>
-          </a:ln>
-        </p:spPr>
-      </p:sp>
-      <p:sp>
-        <p:nvSpPr>
-          <p:cNvPr id="15" name="Rectangle 14">
-            <a:extLst>
-              <a:ext uri="{FF2B5EF4-FFF2-40B4-BE49-F238E27FC236}">
-                <a16:creationId xmlns:a16="http://schemas.microsoft.com/office/drawing/2014/main" id="{80E4E97C-7A0A-4EF4-AF65-50F6DC745965}"/>
-              </a:ext>
-            </a:extLst>
-          </p:cNvPr>
-          <p:cNvSpPr>
-            <a:spLocks noGrp="1"/>
-          </p:cNvSpPr>
-          <p:nvPr/>
-        </p:nvSpPr>
-        <p:spPr>
-          <a:xfrm>
-            <a:off x="781050" y="5457825"/>
             <a:ext cx="47625" cy="1104900"/>
           </a:xfrm>
           <a:prstGeom prst="rect">
@@ -14170,10 +14438,10 @@
       </p:sp>
       <p:sp>
         <p:nvSpPr>
-          <p:cNvPr id="16" name="Rectangle 15">
+          <p:cNvPr id="15" name="Rectangle 14">
             <a:extLst>
               <a:ext uri="{FF2B5EF4-FFF2-40B4-BE49-F238E27FC236}">
-                <a16:creationId xmlns:a16="http://schemas.microsoft.com/office/drawing/2014/main" id="{14CD43E9-AF2E-4919-A83B-095DE5803299}"/>
+                <a16:creationId xmlns:a16="http://schemas.microsoft.com/office/drawing/2014/main" id="{86FFA4C3-5956-4C40-9B1F-D1D44B48C75B}"/>
               </a:ext>
             </a:extLst>
           </p:cNvPr>
@@ -14227,10 +14495,10 @@
       </p:sp>
       <p:sp>
         <p:nvSpPr>
-          <p:cNvPr id="17" name="Rectangle 16">
+          <p:cNvPr id="16" name="Rectangle 15">
             <a:extLst>
               <a:ext uri="{FF2B5EF4-FFF2-40B4-BE49-F238E27FC236}">
-                <a16:creationId xmlns:a16="http://schemas.microsoft.com/office/drawing/2014/main" id="{2A1B2D73-CAFF-484C-BC90-0DD5C45892D7}"/>
+                <a16:creationId xmlns:a16="http://schemas.microsoft.com/office/drawing/2014/main" id="{0A957B4F-745E-4E95-883D-7FACD06E4682}"/>
               </a:ext>
             </a:extLst>
           </p:cNvPr>
@@ -14277,7 +14545,7 @@
                 <a:ea typeface="Calibri"/>
                 <a:cs typeface="Calibri"/>
               </a:rPr>
-              <a:t>The finding also survives balancing the x/y axes. VAE and CVAE are not significantly different; n=3 evidence is mixed.</a:t>
+              <a:t>Paired tests: BH- and Holm-adjusted p &lt; .05. VAE vs CVAE is not significant; n=3 evidence is mixed.</a:t>
             </a:r>
           </a:p>
         </p:txBody>
@@ -14285,7 +14553,7 @@
     </p:spTree>
     <p:extLst>
       <p:ext uri="{BB962C8B-B14F-4D97-AF65-F5344CB8AC3E}">
-        <p14:creationId xmlns:p14="http://schemas.microsoft.com/office/powerpoint/2010/main" val="1128558755"/>
+        <p14:creationId xmlns:p14="http://schemas.microsoft.com/office/powerpoint/2010/main" val="2776356953"/>
       </p:ext>
     </p:extLst>
   </p:cSld>

</xml_diff>